<commit_message>
Actualización presentación Proof of Weight
</commit_message>
<xml_diff>
--- a/Presentaciones/1 Protocolos de consenso/Proof of Weight.pptx
+++ b/Presentaciones/1 Protocolos de consenso/Proof of Weight.pptx
@@ -7096,7 +7096,7 @@
                 <a:cs typeface="Source Sans 3"/>
                 <a:sym typeface="Source Sans 3"/>
               </a:rPr>
-              <a:t>Simulación experimental y resultados</a:t>
+              <a:t>Simulación Experimental y Metodología</a:t>
             </a:r>
           </a:p>
         </p:txBody>
@@ -16715,7 +16715,7 @@
                 <a:cs typeface="Source Sans 3 Bold"/>
                 <a:sym typeface="Source Sans 3 Bold"/>
               </a:rPr>
-              <a:t>6. Simulación Experimental y Resultados</a:t>
+              <a:t>6. Simulación Experimental y Metodología</a:t>
             </a:r>
           </a:p>
         </p:txBody>
@@ -17331,7 +17331,7 @@
         <p:spPr>
           <a:xfrm rot="0">
             <a:off x="12001500" y="5667375"/>
-            <a:ext cx="4667250" cy="1353185"/>
+            <a:ext cx="4667250" cy="1810385"/>
           </a:xfrm>
           <a:prstGeom prst="rect">
             <a:avLst/>
@@ -17343,13 +17343,16 @@
           </a:bodyPr>
           <a:lstStyle/>
           <a:p>
-            <a:pPr algn="l">
+            <a:pPr algn="l" marL="0" indent="0" lvl="0">
               <a:lnSpc>
                 <a:spcPts val="3640"/>
               </a:lnSpc>
+              <a:spcBef>
+                <a:spcPct val="0"/>
+              </a:spcBef>
             </a:pPr>
             <a:r>
-              <a:rPr lang="en-US" sz="2600">
+              <a:rPr lang="en-US" sz="2600" strike="noStrike" u="none">
                 <a:solidFill>
                   <a:srgbClr val="FFFFFF"/>
                 </a:solidFill>
@@ -17358,45 +17361,7 @@
                 <a:cs typeface="Source Sans 3"/>
                 <a:sym typeface="Source Sans 3"/>
               </a:rPr>
-              <a:t>peso = 0.50*tokens</a:t>
-            </a:r>
-          </a:p>
-          <a:p>
-            <a:pPr algn="l">
-              <a:lnSpc>
-                <a:spcPts val="3640"/>
-              </a:lnSpc>
-            </a:pPr>
-            <a:r>
-              <a:rPr lang="en-US" sz="2600">
-                <a:solidFill>
-                  <a:srgbClr val="FFFFFF"/>
-                </a:solidFill>
-                <a:latin typeface="Source Sans 3"/>
-                <a:ea typeface="Source Sans 3"/>
-                <a:cs typeface="Source Sans 3"/>
-                <a:sym typeface="Source Sans 3"/>
-              </a:rPr>
-              <a:t>      + 0.20*antigüedad</a:t>
-            </a:r>
-          </a:p>
-          <a:p>
-            <a:pPr algn="l">
-              <a:lnSpc>
-                <a:spcPts val="3640"/>
-              </a:lnSpc>
-            </a:pPr>
-            <a:r>
-              <a:rPr lang="en-US" sz="2600">
-                <a:solidFill>
-                  <a:srgbClr val="FFFFFF"/>
-                </a:solidFill>
-                <a:latin typeface="Source Sans 3"/>
-                <a:ea typeface="Source Sans 3"/>
-                <a:cs typeface="Source Sans 3"/>
-                <a:sym typeface="Source Sans 3"/>
-              </a:rPr>
-              <a:t>      + 0.30*almacenamiento</a:t>
+              <a:t>Ponderación: El peso combina liquidez (50%), compromiso temporal (20%) y recurso tangible en red (30%)</a:t>
             </a:r>
           </a:p>
         </p:txBody>
@@ -17409,7 +17374,7 @@
         </p:nvGrpSpPr>
         <p:grpSpPr>
           <a:xfrm rot="0">
-            <a:off x="1476375" y="8477250"/>
+            <a:off x="1476375" y="8096250"/>
             <a:ext cx="1428750" cy="619125"/>
             <a:chOff x="0" y="0"/>
             <a:chExt cx="1905000" cy="825500"/>
@@ -17514,7 +17479,7 @@
         </p:nvSpPr>
         <p:spPr>
           <a:xfrm rot="0">
-            <a:off x="1476375" y="8620125"/>
+            <a:off x="1476375" y="8207375"/>
             <a:ext cx="1428750" cy="349250"/>
           </a:xfrm>
           <a:prstGeom prst="rect">
@@ -17555,7 +17520,7 @@
         </p:nvGrpSpPr>
         <p:grpSpPr>
           <a:xfrm rot="0">
-            <a:off x="3476625" y="8477250"/>
+            <a:off x="3476625" y="8096250"/>
             <a:ext cx="1428750" cy="619125"/>
             <a:chOff x="0" y="0"/>
             <a:chExt cx="1905000" cy="825500"/>
@@ -17660,7 +17625,7 @@
         </p:nvSpPr>
         <p:spPr>
           <a:xfrm rot="0">
-            <a:off x="3476625" y="8620125"/>
+            <a:off x="3476625" y="8207375"/>
             <a:ext cx="1428750" cy="349250"/>
           </a:xfrm>
           <a:prstGeom prst="rect">
@@ -17701,7 +17666,7 @@
         </p:nvGrpSpPr>
         <p:grpSpPr>
           <a:xfrm rot="0">
-            <a:off x="5476875" y="8477250"/>
+            <a:off x="5476875" y="8096250"/>
             <a:ext cx="1428750" cy="619125"/>
             <a:chOff x="0" y="0"/>
             <a:chExt cx="1905000" cy="825500"/>
@@ -17806,7 +17771,7 @@
         </p:nvSpPr>
         <p:spPr>
           <a:xfrm rot="0">
-            <a:off x="5476875" y="8620125"/>
+            <a:off x="5476875" y="8207375"/>
             <a:ext cx="1428750" cy="349250"/>
           </a:xfrm>
           <a:prstGeom prst="rect">
@@ -17847,7 +17812,7 @@
         </p:nvGrpSpPr>
         <p:grpSpPr>
           <a:xfrm rot="0">
-            <a:off x="7477125" y="8477250"/>
+            <a:off x="7477125" y="8096250"/>
             <a:ext cx="1428750" cy="619125"/>
             <a:chOff x="0" y="0"/>
             <a:chExt cx="1905000" cy="825500"/>
@@ -17952,7 +17917,7 @@
         </p:nvSpPr>
         <p:spPr>
           <a:xfrm rot="0">
-            <a:off x="7477125" y="8620125"/>
+            <a:off x="7477125" y="8207375"/>
             <a:ext cx="1428750" cy="349250"/>
           </a:xfrm>
           <a:prstGeom prst="rect">
@@ -18022,6 +17987,170 @@
                 <a:sym typeface="Source Sans 3 Bold"/>
               </a:rPr>
               <a:t>POWEIGHT  /  08</a:t>
+            </a:r>
+          </a:p>
+        </p:txBody>
+      </p:sp>
+      <p:sp>
+        <p:nvSpPr>
+          <p:cNvPr name="TextBox 37" id="37"/>
+          <p:cNvSpPr txBox="true"/>
+          <p:nvPr/>
+        </p:nvSpPr>
+        <p:spPr>
+          <a:xfrm rot="0">
+            <a:off x="1476375" y="8867775"/>
+            <a:ext cx="1428750" cy="496570"/>
+          </a:xfrm>
+          <a:prstGeom prst="rect">
+            <a:avLst/>
+          </a:prstGeom>
+        </p:spPr>
+        <p:txBody>
+          <a:bodyPr anchor="t" rtlCol="false" tIns="0" lIns="0" bIns="0" rIns="0">
+            <a:spAutoFit/>
+          </a:bodyPr>
+          <a:lstStyle/>
+          <a:p>
+            <a:pPr algn="ctr">
+              <a:lnSpc>
+                <a:spcPts val="1955"/>
+              </a:lnSpc>
+            </a:pPr>
+            <a:r>
+              <a:rPr lang="en-US" sz="1700">
+                <a:solidFill>
+                  <a:srgbClr val="102738"/>
+                </a:solidFill>
+                <a:latin typeface="Source Sans 3"/>
+                <a:ea typeface="Source Sans 3"/>
+                <a:cs typeface="Source Sans 3"/>
+                <a:sym typeface="Source Sans 3"/>
+              </a:rPr>
+              <a:t>150 tokens · 15 días · 50 GB</a:t>
+            </a:r>
+          </a:p>
+        </p:txBody>
+      </p:sp>
+      <p:sp>
+        <p:nvSpPr>
+          <p:cNvPr name="TextBox 38" id="38"/>
+          <p:cNvSpPr txBox="true"/>
+          <p:nvPr/>
+        </p:nvSpPr>
+        <p:spPr>
+          <a:xfrm rot="0">
+            <a:off x="3476625" y="8867775"/>
+            <a:ext cx="1428750" cy="496570"/>
+          </a:xfrm>
+          <a:prstGeom prst="rect">
+            <a:avLst/>
+          </a:prstGeom>
+        </p:spPr>
+        <p:txBody>
+          <a:bodyPr anchor="t" rtlCol="false" tIns="0" lIns="0" bIns="0" rIns="0">
+            <a:spAutoFit/>
+          </a:bodyPr>
+          <a:lstStyle/>
+          <a:p>
+            <a:pPr algn="ctr">
+              <a:lnSpc>
+                <a:spcPts val="1955"/>
+              </a:lnSpc>
+            </a:pPr>
+            <a:r>
+              <a:rPr lang="en-US" sz="1700">
+                <a:solidFill>
+                  <a:srgbClr val="102738"/>
+                </a:solidFill>
+                <a:latin typeface="Source Sans 3"/>
+                <a:ea typeface="Source Sans 3"/>
+                <a:cs typeface="Source Sans 3"/>
+                <a:sym typeface="Source Sans 3"/>
+              </a:rPr>
+              <a:t>450 tokens · 45 días · 250 GB</a:t>
+            </a:r>
+          </a:p>
+        </p:txBody>
+      </p:sp>
+      <p:sp>
+        <p:nvSpPr>
+          <p:cNvPr name="TextBox 39" id="39"/>
+          <p:cNvSpPr txBox="true"/>
+          <p:nvPr/>
+        </p:nvSpPr>
+        <p:spPr>
+          <a:xfrm rot="0">
+            <a:off x="5476875" y="8867775"/>
+            <a:ext cx="1428750" cy="744220"/>
+          </a:xfrm>
+          <a:prstGeom prst="rect">
+            <a:avLst/>
+          </a:prstGeom>
+        </p:spPr>
+        <p:txBody>
+          <a:bodyPr anchor="t" rtlCol="false" tIns="0" lIns="0" bIns="0" rIns="0">
+            <a:spAutoFit/>
+          </a:bodyPr>
+          <a:lstStyle/>
+          <a:p>
+            <a:pPr algn="ctr">
+              <a:lnSpc>
+                <a:spcPts val="1955"/>
+              </a:lnSpc>
+            </a:pPr>
+            <a:r>
+              <a:rPr lang="en-US" sz="1700">
+                <a:solidFill>
+                  <a:srgbClr val="102738"/>
+                </a:solidFill>
+                <a:latin typeface="Source Sans 3"/>
+                <a:ea typeface="Source Sans 3"/>
+                <a:cs typeface="Source Sans 3"/>
+                <a:sym typeface="Source Sans 3"/>
+              </a:rPr>
+              <a:t>900 tokens · 120 días · 600 GB</a:t>
+            </a:r>
+          </a:p>
+        </p:txBody>
+      </p:sp>
+      <p:sp>
+        <p:nvSpPr>
+          <p:cNvPr name="TextBox 40" id="40"/>
+          <p:cNvSpPr txBox="true"/>
+          <p:nvPr/>
+        </p:nvSpPr>
+        <p:spPr>
+          <a:xfrm rot="0">
+            <a:off x="7477125" y="8867775"/>
+            <a:ext cx="1428750" cy="744220"/>
+          </a:xfrm>
+          <a:prstGeom prst="rect">
+            <a:avLst/>
+          </a:prstGeom>
+        </p:spPr>
+        <p:txBody>
+          <a:bodyPr anchor="t" rtlCol="false" tIns="0" lIns="0" bIns="0" rIns="0">
+            <a:spAutoFit/>
+          </a:bodyPr>
+          <a:lstStyle/>
+          <a:p>
+            <a:pPr algn="ctr">
+              <a:lnSpc>
+                <a:spcPts val="1955"/>
+              </a:lnSpc>
+            </a:pPr>
+            <a:r>
+              <a:rPr lang="en-US" sz="1700">
+                <a:solidFill>
+                  <a:srgbClr val="102738"/>
+                </a:solidFill>
+                <a:latin typeface="Source Sans 3"/>
+                <a:ea typeface="Source Sans 3"/>
+                <a:cs typeface="Source Sans 3"/>
+                <a:sym typeface="Source Sans 3"/>
+              </a:rPr>
+              <a:t>1800 tokens · 240 días · 1500 GB</a:t>
             </a:r>
           </a:p>
         </p:txBody>

</xml_diff>